<commit_message>
Routage PCB 20A, schema de branchement et mise a jour de la presentation
- kicad/ : outils et guide de routage pour tenir 20A (GUIDE_ROUTAGE_20A,
  fix_dsn_widths_20A.py, replan_pcb_20A.py, strip_tracks.py), PCB/schema
  mis a jour en consequence. Routage non termine : il reste 10 pistes a
  tracer (cf. README racine).
- schema_branchement.png et diagramme_cas_utilisation.drawio ajoutes
- presentation de soutenance et GUIDE_MAQUETTE_BOITIER mis a jour
- retire l'ancienne sauvegarde du rapport (avant corrections)

Co-Authored-By: Claude Sonnet 5 <noreply@anthropic.com>
</commit_message>
<xml_diff>
--- a/presentation/TFC_Departageur_Intelligent.pptx
+++ b/presentation/TFC_Departageur_Intelligent.pptx
@@ -4199,7 +4199,7 @@
                 </a:solidFill>
                 <a:latin typeface="Calibri"/>
               </a:rPr>
-              <a:t>Perspectives : V2 — 16 canaux | App Flutter (APK en cours) | Partenariat revendeur agréé (PayIt/Fondeka) pour intégration SOCODEE/Virunga/NURU</a:t>
+              <a:t>Perspectives : V2 — 16 canaux | App Flutter (APK fonctionnel, testee sur maquette physique) | Partenariat revendeur agréé (PayIt/Fondeka) pour intégration SOCODEE/Virunga/NURU</a:t>
             </a:r>
             <a:endParaRPr b="0" lang="fr-FR" sz="800" spc="-1" strike="noStrike">
               <a:solidFill>
@@ -4754,7 +4754,7 @@
                 </a:solidFill>
                 <a:latin typeface="Calibri"/>
               </a:rPr>
-              <a:t>Application Flutter (APK)</a:t>
+              <a:t>App Flutter (3 profils, testee)</a:t>
             </a:r>
             <a:endParaRPr b="0" lang="fr-FR" sz="900" spc="-1" strike="noStrike">
               <a:solidFill>
@@ -7349,7 +7349,7 @@
                 </a:solidFill>
                 <a:latin typeface="Calibri"/>
               </a:rPr>
-              <a:t>05</a:t>
+              <a:t>06</a:t>
             </a:r>
             <a:endParaRPr b="0" lang="fr-FR" sz="1600" spc="-1" strike="noStrike">
               <a:solidFill>
@@ -7405,7 +7405,7 @@
                 </a:solidFill>
                 <a:latin typeface="Calibri"/>
               </a:rPr>
-              <a:t>Conclusion</a:t>
+              <a:t>Démonstration</a:t>
             </a:r>
             <a:endParaRPr b="0" lang="fr-FR" sz="1300" spc="-1" strike="noStrike">
               <a:solidFill>
@@ -7461,7 +7461,7 @@
                 </a:solidFill>
                 <a:latin typeface="Calibri"/>
               </a:rPr>
-              <a:t>Bilan et perspectives</a:t>
+              <a:t>Maquette et application testees en direct</a:t>
             </a:r>
             <a:endParaRPr b="0" lang="fr-FR" sz="900" spc="-1" strike="noStrike">
               <a:solidFill>
@@ -17121,7 +17121,7 @@
                 </a:solidFill>
                 <a:latin typeface="Calibri"/>
               </a:rPr>
-              <a:t>kWh  =  Tension (V)  ×  Courant (A)  ×  Temps (h)  ÷  1000</a:t>
+              <a:t>kWh  =  P active  ×  Temps (h)  ÷  1000   (P calculee, cos(φ) jamais suppose)</a:t>
             </a:r>
             <a:endParaRPr b="0" lang="fr-FR" sz="1600" spc="-1" strike="noStrike">
               <a:solidFill>
@@ -17448,7 +17448,7 @@
                 </a:solidFill>
                 <a:latin typeface="Calibri"/>
               </a:rPr>
-              <a:t>Filtrage : moyenne 100 mesures</a:t>
+              <a:t>Filtrage : moyenne de 8 mesures</a:t>
             </a:r>
             <a:endParaRPr b="0" lang="fr-FR" sz="950" spc="-1" strike="noStrike">
               <a:solidFill>
@@ -17748,7 +17748,7 @@
                 </a:solidFill>
                 <a:latin typeface="Calibri"/>
               </a:rPr>
-              <a:t>Coupure automatique immédiate</a:t>
+              <a:t>Coupure automatique immédiate, ou volontaire (absence)</a:t>
             </a:r>
             <a:endParaRPr b="0" lang="fr-FR" sz="950" spc="-1" strike="noStrike">
               <a:solidFill>

</xml_diff>